<commit_message>
Updated Bernoulli distribution in two files
</commit_message>
<xml_diff>
--- a/statistics_09_History.pptx
+++ b/statistics_09_History.pptx
@@ -21798,9 +21798,7 @@
           <p:cNvGraphicFramePr>
             <a:graphicFrameLocks/>
           </p:cNvGraphicFramePr>
-          <p:nvPr>
-            <p:extLst/>
-          </p:nvPr>
+          <p:nvPr/>
         </p:nvGraphicFramePr>
         <p:xfrm>
           <a:off x="2134920" y="3413230"/>
@@ -27136,8 +27134,8 @@
         </p:nvSpPr>
         <p:spPr>
           <a:xfrm>
-            <a:off x="342900" y="492579"/>
-            <a:ext cx="7515639" cy="4767459"/>
+            <a:off x="235324" y="223638"/>
+            <a:ext cx="7515639" cy="4552015"/>
           </a:xfrm>
           <a:prstGeom prst="rect">
             <a:avLst/>
@@ -27207,7 +27205,7 @@
                 <a:latin typeface="Calibri" panose="020F0502020204030204" pitchFamily="34" charset="0"/>
                 <a:cs typeface="Calibri" panose="020F0502020204030204" pitchFamily="34" charset="0"/>
               </a:rPr>
-              <a:t>" appeared in 1713</a:t>
+              <a:t>" appeared in 1713, eight years after his death.</a:t>
             </a:r>
           </a:p>
           <a:p>
@@ -27220,18 +27218,12 @@
             </a:r>
           </a:p>
           <a:p>
-            <a:endParaRPr lang="en-US" sz="1400" dirty="0">
-              <a:latin typeface="Calibri" panose="020F0502020204030204" pitchFamily="34" charset="0"/>
-              <a:cs typeface="Calibri" panose="020F0502020204030204" pitchFamily="34" charset="0"/>
-            </a:endParaRPr>
-          </a:p>
-          <a:p>
             <a:r>
               <a:rPr lang="en-US" sz="1400" dirty="0">
                 <a:latin typeface="Calibri" panose="020F0502020204030204" pitchFamily="34" charset="0"/>
                 <a:cs typeface="Calibri" panose="020F0502020204030204" pitchFamily="34" charset="0"/>
               </a:rPr>
-              <a:t>Contains the </a:t>
+              <a:t>It contains the </a:t>
             </a:r>
             <a:r>
               <a:rPr lang="en-US" sz="1400" b="1" dirty="0">
@@ -27574,7 +27566,7 @@
         </p:blipFill>
         <p:spPr>
           <a:xfrm>
-            <a:off x="8716735" y="492579"/>
+            <a:off x="8716735" y="195381"/>
             <a:ext cx="2628900" cy="2933700"/>
           </a:xfrm>
           <a:prstGeom prst="rect">
@@ -27596,7 +27588,7 @@
         </p:nvSpPr>
         <p:spPr>
           <a:xfrm>
-            <a:off x="8635094" y="3477983"/>
+            <a:off x="8635094" y="3180785"/>
             <a:ext cx="2792186" cy="738664"/>
           </a:xfrm>
           <a:prstGeom prst="rect">
@@ -27654,6 +27646,159 @@
                 <a:cs typeface="Calibri" panose="020F0502020204030204" pitchFamily="34" charset="0"/>
               </a:rPr>
               <a:t>1655 – 1705</a:t>
+            </a:r>
+          </a:p>
+        </p:txBody>
+      </p:sp>
+      <p:sp>
+        <p:nvSpPr>
+          <p:cNvPr id="7" name="TextBox 6">
+            <a:extLst>
+              <a:ext uri="{FF2B5EF4-FFF2-40B4-BE49-F238E27FC236}">
+                <a16:creationId xmlns:a16="http://schemas.microsoft.com/office/drawing/2014/main" id="{0E556000-6689-3D41-9EC2-EFC3354B5E67}"/>
+              </a:ext>
+            </a:extLst>
+          </p:cNvPr>
+          <p:cNvSpPr txBox="1"/>
+          <p:nvPr/>
+        </p:nvSpPr>
+        <p:spPr>
+          <a:xfrm>
+            <a:off x="9238265" y="6139399"/>
+            <a:ext cx="1643270" cy="523220"/>
+          </a:xfrm>
+          <a:prstGeom prst="rect">
+            <a:avLst/>
+          </a:prstGeom>
+          <a:noFill/>
+        </p:spPr>
+        <p:txBody>
+          <a:bodyPr wrap="square" rtlCol="0">
+            <a:spAutoFit/>
+          </a:bodyPr>
+          <a:lstStyle/>
+          <a:p>
+            <a:pPr algn="ctr"/>
+            <a:r>
+              <a:rPr lang="en-US" dirty="0"/>
+              <a:t>Daniel Bernoulli</a:t>
+            </a:r>
+          </a:p>
+          <a:p>
+            <a:pPr algn="ctr"/>
+            <a:r>
+              <a:rPr lang="en-US" dirty="0"/>
+              <a:t>(1700 - 1782)</a:t>
+            </a:r>
+          </a:p>
+        </p:txBody>
+      </p:sp>
+      <p:pic>
+        <p:nvPicPr>
+          <p:cNvPr id="8" name="Picture 7">
+            <a:extLst>
+              <a:ext uri="{FF2B5EF4-FFF2-40B4-BE49-F238E27FC236}">
+                <a16:creationId xmlns:a16="http://schemas.microsoft.com/office/drawing/2014/main" id="{B3C4FA4B-624C-3146-BDB7-F57F88A1551B}"/>
+              </a:ext>
+            </a:extLst>
+          </p:cNvPr>
+          <p:cNvPicPr>
+            <a:picLocks noChangeAspect="1"/>
+          </p:cNvPicPr>
+          <p:nvPr/>
+        </p:nvPicPr>
+        <p:blipFill rotWithShape="1">
+          <a:blip r:embed="rId3" cstate="email">
+            <a:extLst>
+              <a:ext uri="{28A0092B-C50C-407E-A947-70E740481C1C}">
+                <a14:useLocalDpi xmlns:a14="http://schemas.microsoft.com/office/drawing/2010/main"/>
+              </a:ext>
+            </a:extLst>
+          </a:blip>
+          <a:srcRect/>
+          <a:stretch/>
+        </p:blipFill>
+        <p:spPr>
+          <a:xfrm>
+            <a:off x="9564211" y="4664835"/>
+            <a:ext cx="1130715" cy="1375159"/>
+          </a:xfrm>
+          <a:prstGeom prst="rect">
+            <a:avLst/>
+          </a:prstGeom>
+        </p:spPr>
+      </p:pic>
+      <p:sp>
+        <p:nvSpPr>
+          <p:cNvPr id="2" name="TextBox 1">
+            <a:extLst>
+              <a:ext uri="{FF2B5EF4-FFF2-40B4-BE49-F238E27FC236}">
+                <a16:creationId xmlns:a16="http://schemas.microsoft.com/office/drawing/2014/main" id="{2EA4DA3D-566A-AF49-8A05-FB592C429D63}"/>
+              </a:ext>
+            </a:extLst>
+          </p:cNvPr>
+          <p:cNvSpPr txBox="1"/>
+          <p:nvPr/>
+        </p:nvSpPr>
+        <p:spPr>
+          <a:xfrm>
+            <a:off x="2832847" y="5562940"/>
+            <a:ext cx="6526306" cy="954107"/>
+          </a:xfrm>
+          <a:prstGeom prst="rect">
+            <a:avLst/>
+          </a:prstGeom>
+          <a:noFill/>
+        </p:spPr>
+        <p:txBody>
+          <a:bodyPr wrap="square" rtlCol="0">
+            <a:spAutoFit/>
+          </a:bodyPr>
+          <a:lstStyle/>
+          <a:p>
+            <a:r>
+              <a:rPr lang="en-US" b="1" dirty="0">
+                <a:solidFill>
+                  <a:srgbClr val="0070C0"/>
+                </a:solidFill>
+                <a:latin typeface="Calibri" panose="020F0502020204030204" pitchFamily="34" charset="0"/>
+                <a:cs typeface="Calibri" panose="020F0502020204030204" pitchFamily="34" charset="0"/>
+              </a:rPr>
+              <a:t>Daniel Bernoulli </a:t>
+            </a:r>
+            <a:r>
+              <a:rPr lang="en-US" dirty="0">
+                <a:solidFill>
+                  <a:schemeClr val="tx1"/>
+                </a:solidFill>
+                <a:latin typeface="Calibri" panose="020F0502020204030204" pitchFamily="34" charset="0"/>
+                <a:cs typeface="Calibri" panose="020F0502020204030204" pitchFamily="34" charset="0"/>
+              </a:rPr>
+              <a:t>was one of eight prominent mathematicians in the Bernoulli family from Basel.</a:t>
+            </a:r>
+          </a:p>
+          <a:p>
+            <a:r>
+              <a:rPr lang="en-US" dirty="0">
+                <a:solidFill>
+                  <a:schemeClr val="tx1"/>
+                </a:solidFill>
+                <a:latin typeface="Calibri" panose="020F0502020204030204" pitchFamily="34" charset="0"/>
+                <a:cs typeface="Calibri" panose="020F0502020204030204" pitchFamily="34" charset="0"/>
+              </a:rPr>
+              <a:t>He has derived Gamma function for complex numbers with a positive real part.</a:t>
+            </a:r>
+          </a:p>
+          <a:p>
+            <a:r>
+              <a:rPr lang="en-US" dirty="0">
+                <a:solidFill>
+                  <a:schemeClr val="tx1"/>
+                </a:solidFill>
+                <a:latin typeface="Calibri" panose="020F0502020204030204" pitchFamily="34" charset="0"/>
+                <a:cs typeface="Calibri" panose="020F0502020204030204" pitchFamily="34" charset="0"/>
+              </a:rPr>
+              <a:t>He has contributed to fluid mechanics, probability and statistics. </a:t>
             </a:r>
           </a:p>
         </p:txBody>

</xml_diff>